<commit_message>
Remove speed lines from title slide
</commit_message>
<xml_diff>
--- a/docs/social_fitness_media_intelligence.pptx
+++ b/docs/social_fitness_media_intelligence.pptx
@@ -2040,8 +2040,371 @@
         </p:nvSpPr>
         <p:spPr>
           <a:xfrm>
-            <a:off x="-914400" y="0"/>
-            <a:ext cx="13716" cy="5143500"/>
+            <a:off x="0" y="0"/>
+            <a:ext cx="73152" cy="5143500"/>
+          </a:xfrm>
+          <a:prstGeom prst="rect">
+            <a:avLst/>
+          </a:prstGeom>
+          <a:solidFill>
+            <a:srgbClr val="FC4C02"/>
+          </a:solidFill>
+          <a:ln w="12700">
+            <a:solidFill>
+              <a:srgbClr val="FC4C02"/>
+            </a:solidFill>
+            <a:prstDash val="solid"/>
+          </a:ln>
+        </p:spPr>
+      </p:sp>
+      <p:sp>
+        <p:nvSpPr>
+          <p:cNvPr id="3" name="Text 1"/>
+          <p:cNvSpPr/>
+          <p:nvPr/>
+        </p:nvSpPr>
+        <p:spPr>
+          <a:xfrm>
+            <a:off x="502920" y="640080"/>
+            <a:ext cx="5303520" cy="2011680"/>
+          </a:xfrm>
+          <a:prstGeom prst="rect">
+            <a:avLst/>
+          </a:prstGeom>
+          <a:noFill/>
+          <a:ln/>
+        </p:spPr>
+        <p:txBody>
+          <a:bodyPr wrap="square" rtlCol="0" anchor="ctr"/>
+          <a:lstStyle/>
+          <a:p>
+            <a:pPr indent="0" marL="0">
+              <a:lnSpc>
+                <a:spcPct val="110000"/>
+              </a:lnSpc>
+              <a:buNone/>
+            </a:pPr>
+            <a:r>
+              <a:rPr lang="en-US" sz="4400" b="1" dirty="0">
+                <a:solidFill>
+                  <a:srgbClr val="F4F4F0"/>
+                </a:solidFill>
+                <a:latin typeface="Calibri" pitchFamily="34" charset="0"/>
+                <a:ea typeface="Calibri" pitchFamily="34" charset="-122"/>
+                <a:cs typeface="Calibri" pitchFamily="34" charset="-120"/>
+              </a:rPr>
+              <a:t>Social Fitness</a:t>
+            </a:r>
+            <a:endParaRPr lang="en-US" sz="4400" dirty="0"/>
+          </a:p>
+          <a:p>
+            <a:pPr indent="0" marL="0">
+              <a:lnSpc>
+                <a:spcPct val="110000"/>
+              </a:lnSpc>
+              <a:buNone/>
+            </a:pPr>
+            <a:r>
+              <a:rPr lang="en-US" sz="4400" b="1" dirty="0">
+                <a:solidFill>
+                  <a:srgbClr val="F4F4F0"/>
+                </a:solidFill>
+                <a:latin typeface="Calibri" pitchFamily="34" charset="0"/>
+                <a:ea typeface="Calibri" pitchFamily="34" charset="-122"/>
+                <a:cs typeface="Calibri" pitchFamily="34" charset="-120"/>
+              </a:rPr>
+              <a:t>Tracker App</a:t>
+            </a:r>
+            <a:endParaRPr lang="en-US" sz="4400" dirty="0"/>
+          </a:p>
+        </p:txBody>
+      </p:sp>
+      <p:sp>
+        <p:nvSpPr>
+          <p:cNvPr id="4" name="Text 2"/>
+          <p:cNvSpPr/>
+          <p:nvPr/>
+        </p:nvSpPr>
+        <p:spPr>
+          <a:xfrm>
+            <a:off x="502920" y="2697480"/>
+            <a:ext cx="5303520" cy="457200"/>
+          </a:xfrm>
+          <a:prstGeom prst="rect">
+            <a:avLst/>
+          </a:prstGeom>
+          <a:noFill/>
+          <a:ln/>
+        </p:spPr>
+        <p:txBody>
+          <a:bodyPr wrap="square" rtlCol="0" anchor="ctr"/>
+          <a:lstStyle/>
+          <a:p>
+            <a:pPr indent="0" marL="0">
+              <a:buNone/>
+            </a:pPr>
+            <a:r>
+              <a:rPr lang="en-US" sz="2000" b="1" dirty="0">
+                <a:solidFill>
+                  <a:srgbClr val="FC4C02"/>
+                </a:solidFill>
+                <a:latin typeface="Calibri" pitchFamily="34" charset="0"/>
+                <a:ea typeface="Calibri" pitchFamily="34" charset="-122"/>
+                <a:cs typeface="Calibri" pitchFamily="34" charset="-120"/>
+              </a:rPr>
+              <a:t>Media Intelligence Platform</a:t>
+            </a:r>
+            <a:endParaRPr lang="en-US" sz="2000" dirty="0"/>
+          </a:p>
+        </p:txBody>
+      </p:sp>
+      <p:sp>
+        <p:nvSpPr>
+          <p:cNvPr id="5" name="Text 3"/>
+          <p:cNvSpPr/>
+          <p:nvPr/>
+        </p:nvSpPr>
+        <p:spPr>
+          <a:xfrm>
+            <a:off x="502920" y="3218688"/>
+            <a:ext cx="5303520" cy="365760"/>
+          </a:xfrm>
+          <a:prstGeom prst="rect">
+            <a:avLst/>
+          </a:prstGeom>
+          <a:noFill/>
+          <a:ln/>
+        </p:spPr>
+        <p:txBody>
+          <a:bodyPr wrap="square" rtlCol="0" anchor="ctr"/>
+          <a:lstStyle/>
+          <a:p>
+            <a:pPr indent="0" marL="0">
+              <a:buNone/>
+            </a:pPr>
+            <a:r>
+              <a:rPr lang="en-US" sz="1200" dirty="0">
+                <a:solidFill>
+                  <a:srgbClr val="9B9BA0"/>
+                </a:solidFill>
+                <a:latin typeface="Calibri" pitchFamily="34" charset="0"/>
+                <a:ea typeface="Calibri" pitchFamily="34" charset="-122"/>
+                <a:cs typeface="Calibri" pitchFamily="34" charset="-120"/>
+              </a:rPr>
+              <a:t>End-to-end ETL pipeline · Full-funnel measurement · Downstream advanced analytics</a:t>
+            </a:r>
+            <a:endParaRPr lang="en-US" sz="1200" dirty="0"/>
+          </a:p>
+        </p:txBody>
+      </p:sp>
+      <p:sp>
+        <p:nvSpPr>
+          <p:cNvPr id="6" name="Shape 4"/>
+          <p:cNvSpPr/>
+          <p:nvPr/>
+        </p:nvSpPr>
+        <p:spPr>
+          <a:xfrm>
+            <a:off x="5943600" y="914400"/>
+            <a:ext cx="2651760" cy="347472"/>
+          </a:xfrm>
+          <a:prstGeom prst="rect">
+            <a:avLst/>
+          </a:prstGeom>
+          <a:solidFill>
+            <a:srgbClr val="FF2D55">
+              <a:alpha val="12000"/>
+            </a:srgbClr>
+          </a:solidFill>
+          <a:ln w="10160">
+            <a:solidFill>
+              <a:srgbClr val="FF2D55"/>
+            </a:solidFill>
+            <a:prstDash val="solid"/>
+          </a:ln>
+        </p:spPr>
+      </p:sp>
+      <p:sp>
+        <p:nvSpPr>
+          <p:cNvPr id="7" name="Text 5"/>
+          <p:cNvSpPr/>
+          <p:nvPr/>
+        </p:nvSpPr>
+        <p:spPr>
+          <a:xfrm>
+            <a:off x="6080760" y="914400"/>
+            <a:ext cx="2651760" cy="347472"/>
+          </a:xfrm>
+          <a:prstGeom prst="rect">
+            <a:avLst/>
+          </a:prstGeom>
+          <a:noFill/>
+          <a:ln/>
+        </p:spPr>
+        <p:txBody>
+          <a:bodyPr wrap="square" rtlCol="0" anchor="ctr"/>
+          <a:lstStyle/>
+          <a:p>
+            <a:pPr indent="0" marL="0">
+              <a:buNone/>
+            </a:pPr>
+            <a:r>
+              <a:rPr lang="en-US" sz="1200" b="1" dirty="0">
+                <a:solidFill>
+                  <a:srgbClr val="FF2D55"/>
+                </a:solidFill>
+                <a:latin typeface="Calibri" pitchFamily="34" charset="0"/>
+                <a:ea typeface="Calibri" pitchFamily="34" charset="-122"/>
+                <a:cs typeface="Calibri" pitchFamily="34" charset="-120"/>
+              </a:rPr>
+              <a:t>TikTok Ads</a:t>
+            </a:r>
+            <a:endParaRPr lang="en-US" sz="1200" dirty="0"/>
+          </a:p>
+        </p:txBody>
+      </p:sp>
+      <p:sp>
+        <p:nvSpPr>
+          <p:cNvPr id="8" name="Shape 6"/>
+          <p:cNvSpPr/>
+          <p:nvPr/>
+        </p:nvSpPr>
+        <p:spPr>
+          <a:xfrm>
+            <a:off x="5943600" y="1463040"/>
+            <a:ext cx="2651760" cy="347472"/>
+          </a:xfrm>
+          <a:prstGeom prst="rect">
+            <a:avLst/>
+          </a:prstGeom>
+          <a:solidFill>
+            <a:srgbClr val="40A0FF">
+              <a:alpha val="12000"/>
+            </a:srgbClr>
+          </a:solidFill>
+          <a:ln w="10160">
+            <a:solidFill>
+              <a:srgbClr val="40A0FF"/>
+            </a:solidFill>
+            <a:prstDash val="solid"/>
+          </a:ln>
+        </p:spPr>
+      </p:sp>
+      <p:sp>
+        <p:nvSpPr>
+          <p:cNvPr id="9" name="Text 7"/>
+          <p:cNvSpPr/>
+          <p:nvPr/>
+        </p:nvSpPr>
+        <p:spPr>
+          <a:xfrm>
+            <a:off x="6080760" y="1463040"/>
+            <a:ext cx="2651760" cy="347472"/>
+          </a:xfrm>
+          <a:prstGeom prst="rect">
+            <a:avLst/>
+          </a:prstGeom>
+          <a:noFill/>
+          <a:ln/>
+        </p:spPr>
+        <p:txBody>
+          <a:bodyPr wrap="square" rtlCol="0" anchor="ctr"/>
+          <a:lstStyle/>
+          <a:p>
+            <a:pPr indent="0" marL="0">
+              <a:buNone/>
+            </a:pPr>
+            <a:r>
+              <a:rPr lang="en-US" sz="1200" b="1" dirty="0">
+                <a:solidFill>
+                  <a:srgbClr val="40A0FF"/>
+                </a:solidFill>
+                <a:latin typeface="Calibri" pitchFamily="34" charset="0"/>
+                <a:ea typeface="Calibri" pitchFamily="34" charset="-122"/>
+                <a:cs typeface="Calibri" pitchFamily="34" charset="-120"/>
+              </a:rPr>
+              <a:t>Meta / Instagram</a:t>
+            </a:r>
+            <a:endParaRPr lang="en-US" sz="1200" dirty="0"/>
+          </a:p>
+        </p:txBody>
+      </p:sp>
+      <p:sp>
+        <p:nvSpPr>
+          <p:cNvPr id="10" name="Shape 8"/>
+          <p:cNvSpPr/>
+          <p:nvPr/>
+        </p:nvSpPr>
+        <p:spPr>
+          <a:xfrm>
+            <a:off x="5943600" y="2011680"/>
+            <a:ext cx="2651760" cy="347472"/>
+          </a:xfrm>
+          <a:prstGeom prst="rect">
+            <a:avLst/>
+          </a:prstGeom>
+          <a:solidFill>
+            <a:srgbClr val="FF6A35">
+              <a:alpha val="12000"/>
+            </a:srgbClr>
+          </a:solidFill>
+          <a:ln w="10160">
+            <a:solidFill>
+              <a:srgbClr val="FF6A35"/>
+            </a:solidFill>
+            <a:prstDash val="solid"/>
+          </a:ln>
+        </p:spPr>
+      </p:sp>
+      <p:sp>
+        <p:nvSpPr>
+          <p:cNvPr id="11" name="Text 9"/>
+          <p:cNvSpPr/>
+          <p:nvPr/>
+        </p:nvSpPr>
+        <p:spPr>
+          <a:xfrm>
+            <a:off x="6080760" y="2011680"/>
+            <a:ext cx="2651760" cy="347472"/>
+          </a:xfrm>
+          <a:prstGeom prst="rect">
+            <a:avLst/>
+          </a:prstGeom>
+          <a:noFill/>
+          <a:ln/>
+        </p:spPr>
+        <p:txBody>
+          <a:bodyPr wrap="square" rtlCol="0" anchor="ctr"/>
+          <a:lstStyle/>
+          <a:p>
+            <a:pPr indent="0" marL="0">
+              <a:buNone/>
+            </a:pPr>
+            <a:r>
+              <a:rPr lang="en-US" sz="1200" b="1" dirty="0">
+                <a:solidFill>
+                  <a:srgbClr val="FF6A35"/>
+                </a:solidFill>
+                <a:latin typeface="Calibri" pitchFamily="34" charset="0"/>
+                <a:ea typeface="Calibri" pitchFamily="34" charset="-122"/>
+                <a:cs typeface="Calibri" pitchFamily="34" charset="-120"/>
+              </a:rPr>
+              <a:t>Reddit Ads</a:t>
+            </a:r>
+            <a:endParaRPr lang="en-US" sz="1200" dirty="0"/>
+          </a:p>
+        </p:txBody>
+      </p:sp>
+      <p:sp>
+        <p:nvSpPr>
+          <p:cNvPr id="12" name="Shape 10"/>
+          <p:cNvSpPr/>
+          <p:nvPr/>
+        </p:nvSpPr>
+        <p:spPr>
+          <a:xfrm>
+            <a:off x="5943600" y="2560320"/>
+            <a:ext cx="2651760" cy="347472"/>
           </a:xfrm>
           <a:prstGeom prst="rect">
             <a:avLst/>
@@ -2051,7 +2414,7 @@
               <a:alpha val="12000"/>
             </a:srgbClr>
           </a:solidFill>
-          <a:ln w="12700">
+          <a:ln w="10160">
             <a:solidFill>
               <a:srgbClr val="FC4C02"/>
             </a:solidFill>
@@ -2061,586 +2424,7 @@
       </p:sp>
       <p:sp>
         <p:nvSpPr>
-          <p:cNvPr id="3" name="Shape 1"/>
-          <p:cNvSpPr/>
-          <p:nvPr/>
-        </p:nvSpPr>
-        <p:spPr>
-          <a:xfrm>
-            <a:off x="548640" y="0"/>
-            <a:ext cx="13716" cy="5143500"/>
-          </a:xfrm>
-          <a:prstGeom prst="rect">
-            <a:avLst/>
-          </a:prstGeom>
-          <a:solidFill>
-            <a:srgbClr val="FC4C02">
-              <a:alpha val="12000"/>
-            </a:srgbClr>
-          </a:solidFill>
-          <a:ln w="12700">
-            <a:solidFill>
-              <a:srgbClr val="FC4C02"/>
-            </a:solidFill>
-            <a:prstDash val="solid"/>
-          </a:ln>
-        </p:spPr>
-      </p:sp>
-      <p:sp>
-        <p:nvSpPr>
-          <p:cNvPr id="4" name="Shape 2"/>
-          <p:cNvSpPr/>
-          <p:nvPr/>
-        </p:nvSpPr>
-        <p:spPr>
-          <a:xfrm>
-            <a:off x="2011680" y="0"/>
-            <a:ext cx="13716" cy="5143500"/>
-          </a:xfrm>
-          <a:prstGeom prst="rect">
-            <a:avLst/>
-          </a:prstGeom>
-          <a:solidFill>
-            <a:srgbClr val="FC4C02">
-              <a:alpha val="12000"/>
-            </a:srgbClr>
-          </a:solidFill>
-          <a:ln w="12700">
-            <a:solidFill>
-              <a:srgbClr val="FC4C02"/>
-            </a:solidFill>
-            <a:prstDash val="solid"/>
-          </a:ln>
-        </p:spPr>
-      </p:sp>
-      <p:sp>
-        <p:nvSpPr>
-          <p:cNvPr id="5" name="Shape 3"/>
-          <p:cNvSpPr/>
-          <p:nvPr/>
-        </p:nvSpPr>
-        <p:spPr>
-          <a:xfrm>
-            <a:off x="3474720" y="0"/>
-            <a:ext cx="13716" cy="5143500"/>
-          </a:xfrm>
-          <a:prstGeom prst="rect">
-            <a:avLst/>
-          </a:prstGeom>
-          <a:solidFill>
-            <a:srgbClr val="FC4C02">
-              <a:alpha val="12000"/>
-            </a:srgbClr>
-          </a:solidFill>
-          <a:ln w="12700">
-            <a:solidFill>
-              <a:srgbClr val="FC4C02"/>
-            </a:solidFill>
-            <a:prstDash val="solid"/>
-          </a:ln>
-        </p:spPr>
-      </p:sp>
-      <p:sp>
-        <p:nvSpPr>
-          <p:cNvPr id="6" name="Shape 4"/>
-          <p:cNvSpPr/>
-          <p:nvPr/>
-        </p:nvSpPr>
-        <p:spPr>
-          <a:xfrm>
-            <a:off x="4937760" y="0"/>
-            <a:ext cx="13716" cy="5143500"/>
-          </a:xfrm>
-          <a:prstGeom prst="rect">
-            <a:avLst/>
-          </a:prstGeom>
-          <a:solidFill>
-            <a:srgbClr val="FC4C02">
-              <a:alpha val="12000"/>
-            </a:srgbClr>
-          </a:solidFill>
-          <a:ln w="12700">
-            <a:solidFill>
-              <a:srgbClr val="FC4C02"/>
-            </a:solidFill>
-            <a:prstDash val="solid"/>
-          </a:ln>
-        </p:spPr>
-      </p:sp>
-      <p:sp>
-        <p:nvSpPr>
-          <p:cNvPr id="7" name="Shape 5"/>
-          <p:cNvSpPr/>
-          <p:nvPr/>
-        </p:nvSpPr>
-        <p:spPr>
-          <a:xfrm>
-            <a:off x="6400800" y="0"/>
-            <a:ext cx="13716" cy="5143500"/>
-          </a:xfrm>
-          <a:prstGeom prst="rect">
-            <a:avLst/>
-          </a:prstGeom>
-          <a:solidFill>
-            <a:srgbClr val="FC4C02">
-              <a:alpha val="12000"/>
-            </a:srgbClr>
-          </a:solidFill>
-          <a:ln w="12700">
-            <a:solidFill>
-              <a:srgbClr val="FC4C02"/>
-            </a:solidFill>
-            <a:prstDash val="solid"/>
-          </a:ln>
-        </p:spPr>
-      </p:sp>
-      <p:sp>
-        <p:nvSpPr>
-          <p:cNvPr id="8" name="Shape 6"/>
-          <p:cNvSpPr/>
-          <p:nvPr/>
-        </p:nvSpPr>
-        <p:spPr>
-          <a:xfrm>
-            <a:off x="7863840" y="0"/>
-            <a:ext cx="13716" cy="5143500"/>
-          </a:xfrm>
-          <a:prstGeom prst="rect">
-            <a:avLst/>
-          </a:prstGeom>
-          <a:solidFill>
-            <a:srgbClr val="FC4C02">
-              <a:alpha val="12000"/>
-            </a:srgbClr>
-          </a:solidFill>
-          <a:ln w="12700">
-            <a:solidFill>
-              <a:srgbClr val="FC4C02"/>
-            </a:solidFill>
-            <a:prstDash val="solid"/>
-          </a:ln>
-        </p:spPr>
-      </p:sp>
-      <p:sp>
-        <p:nvSpPr>
-          <p:cNvPr id="9" name="Shape 7"/>
-          <p:cNvSpPr/>
-          <p:nvPr/>
-        </p:nvSpPr>
-        <p:spPr>
-          <a:xfrm>
-            <a:off x="9326880" y="0"/>
-            <a:ext cx="13716" cy="5143500"/>
-          </a:xfrm>
-          <a:prstGeom prst="rect">
-            <a:avLst/>
-          </a:prstGeom>
-          <a:solidFill>
-            <a:srgbClr val="FC4C02">
-              <a:alpha val="12000"/>
-            </a:srgbClr>
-          </a:solidFill>
-          <a:ln w="12700">
-            <a:solidFill>
-              <a:srgbClr val="FC4C02"/>
-            </a:solidFill>
-            <a:prstDash val="solid"/>
-          </a:ln>
-        </p:spPr>
-      </p:sp>
-      <p:sp>
-        <p:nvSpPr>
-          <p:cNvPr id="10" name="Shape 8"/>
-          <p:cNvSpPr/>
-          <p:nvPr/>
-        </p:nvSpPr>
-        <p:spPr>
-          <a:xfrm>
-            <a:off x="0" y="0"/>
-            <a:ext cx="73152" cy="5143500"/>
-          </a:xfrm>
-          <a:prstGeom prst="rect">
-            <a:avLst/>
-          </a:prstGeom>
-          <a:solidFill>
-            <a:srgbClr val="FC4C02"/>
-          </a:solidFill>
-          <a:ln w="12700">
-            <a:solidFill>
-              <a:srgbClr val="FC4C02"/>
-            </a:solidFill>
-            <a:prstDash val="solid"/>
-          </a:ln>
-        </p:spPr>
-      </p:sp>
-      <p:sp>
-        <p:nvSpPr>
-          <p:cNvPr id="11" name="Text 9"/>
-          <p:cNvSpPr/>
-          <p:nvPr/>
-        </p:nvSpPr>
-        <p:spPr>
-          <a:xfrm>
-            <a:off x="502920" y="640080"/>
-            <a:ext cx="5303520" cy="2011680"/>
-          </a:xfrm>
-          <a:prstGeom prst="rect">
-            <a:avLst/>
-          </a:prstGeom>
-          <a:noFill/>
-          <a:ln/>
-        </p:spPr>
-        <p:txBody>
-          <a:bodyPr wrap="square" rtlCol="0" anchor="ctr"/>
-          <a:lstStyle/>
-          <a:p>
-            <a:pPr indent="0" marL="0">
-              <a:lnSpc>
-                <a:spcPct val="110000"/>
-              </a:lnSpc>
-              <a:buNone/>
-            </a:pPr>
-            <a:r>
-              <a:rPr lang="en-US" sz="4400" b="1" dirty="0">
-                <a:solidFill>
-                  <a:srgbClr val="F4F4F0"/>
-                </a:solidFill>
-                <a:latin typeface="Calibri" pitchFamily="34" charset="0"/>
-                <a:ea typeface="Calibri" pitchFamily="34" charset="-122"/>
-                <a:cs typeface="Calibri" pitchFamily="34" charset="-120"/>
-              </a:rPr>
-              <a:t>Social Fitness</a:t>
-            </a:r>
-            <a:endParaRPr lang="en-US" sz="4400" dirty="0"/>
-          </a:p>
-          <a:p>
-            <a:pPr indent="0" marL="0">
-              <a:lnSpc>
-                <a:spcPct val="110000"/>
-              </a:lnSpc>
-              <a:buNone/>
-            </a:pPr>
-            <a:r>
-              <a:rPr lang="en-US" sz="4400" b="1" dirty="0">
-                <a:solidFill>
-                  <a:srgbClr val="F4F4F0"/>
-                </a:solidFill>
-                <a:latin typeface="Calibri" pitchFamily="34" charset="0"/>
-                <a:ea typeface="Calibri" pitchFamily="34" charset="-122"/>
-                <a:cs typeface="Calibri" pitchFamily="34" charset="-120"/>
-              </a:rPr>
-              <a:t>Tracker App</a:t>
-            </a:r>
-            <a:endParaRPr lang="en-US" sz="4400" dirty="0"/>
-          </a:p>
-        </p:txBody>
-      </p:sp>
-      <p:sp>
-        <p:nvSpPr>
-          <p:cNvPr id="12" name="Text 10"/>
-          <p:cNvSpPr/>
-          <p:nvPr/>
-        </p:nvSpPr>
-        <p:spPr>
-          <a:xfrm>
-            <a:off x="502920" y="2697480"/>
-            <a:ext cx="5303520" cy="457200"/>
-          </a:xfrm>
-          <a:prstGeom prst="rect">
-            <a:avLst/>
-          </a:prstGeom>
-          <a:noFill/>
-          <a:ln/>
-        </p:spPr>
-        <p:txBody>
-          <a:bodyPr wrap="square" rtlCol="0" anchor="ctr"/>
-          <a:lstStyle/>
-          <a:p>
-            <a:pPr indent="0" marL="0">
-              <a:buNone/>
-            </a:pPr>
-            <a:r>
-              <a:rPr lang="en-US" sz="2000" b="1" dirty="0">
-                <a:solidFill>
-                  <a:srgbClr val="FC4C02"/>
-                </a:solidFill>
-                <a:latin typeface="Calibri" pitchFamily="34" charset="0"/>
-                <a:ea typeface="Calibri" pitchFamily="34" charset="-122"/>
-                <a:cs typeface="Calibri" pitchFamily="34" charset="-120"/>
-              </a:rPr>
-              <a:t>Media Intelligence Platform</a:t>
-            </a:r>
-            <a:endParaRPr lang="en-US" sz="2000" dirty="0"/>
-          </a:p>
-        </p:txBody>
-      </p:sp>
-      <p:sp>
-        <p:nvSpPr>
           <p:cNvPr id="13" name="Text 11"/>
-          <p:cNvSpPr/>
-          <p:nvPr/>
-        </p:nvSpPr>
-        <p:spPr>
-          <a:xfrm>
-            <a:off x="502920" y="3218688"/>
-            <a:ext cx="5303520" cy="365760"/>
-          </a:xfrm>
-          <a:prstGeom prst="rect">
-            <a:avLst/>
-          </a:prstGeom>
-          <a:noFill/>
-          <a:ln/>
-        </p:spPr>
-        <p:txBody>
-          <a:bodyPr wrap="square" rtlCol="0" anchor="ctr"/>
-          <a:lstStyle/>
-          <a:p>
-            <a:pPr indent="0" marL="0">
-              <a:buNone/>
-            </a:pPr>
-            <a:r>
-              <a:rPr lang="en-US" sz="1200" dirty="0">
-                <a:solidFill>
-                  <a:srgbClr val="9B9BA0"/>
-                </a:solidFill>
-                <a:latin typeface="Calibri" pitchFamily="34" charset="0"/>
-                <a:ea typeface="Calibri" pitchFamily="34" charset="-122"/>
-                <a:cs typeface="Calibri" pitchFamily="34" charset="-120"/>
-              </a:rPr>
-              <a:t>End-to-end ETL pipeline · Full-funnel measurement · Downstream advanced analytics</a:t>
-            </a:r>
-            <a:endParaRPr lang="en-US" sz="1200" dirty="0"/>
-          </a:p>
-        </p:txBody>
-      </p:sp>
-      <p:sp>
-        <p:nvSpPr>
-          <p:cNvPr id="14" name="Shape 12"/>
-          <p:cNvSpPr/>
-          <p:nvPr/>
-        </p:nvSpPr>
-        <p:spPr>
-          <a:xfrm>
-            <a:off x="5943600" y="914400"/>
-            <a:ext cx="2651760" cy="347472"/>
-          </a:xfrm>
-          <a:prstGeom prst="rect">
-            <a:avLst/>
-          </a:prstGeom>
-          <a:solidFill>
-            <a:srgbClr val="FF2D55">
-              <a:alpha val="12000"/>
-            </a:srgbClr>
-          </a:solidFill>
-          <a:ln w="10160">
-            <a:solidFill>
-              <a:srgbClr val="FF2D55"/>
-            </a:solidFill>
-            <a:prstDash val="solid"/>
-          </a:ln>
-        </p:spPr>
-      </p:sp>
-      <p:sp>
-        <p:nvSpPr>
-          <p:cNvPr id="15" name="Text 13"/>
-          <p:cNvSpPr/>
-          <p:nvPr/>
-        </p:nvSpPr>
-        <p:spPr>
-          <a:xfrm>
-            <a:off x="6080760" y="914400"/>
-            <a:ext cx="2651760" cy="347472"/>
-          </a:xfrm>
-          <a:prstGeom prst="rect">
-            <a:avLst/>
-          </a:prstGeom>
-          <a:noFill/>
-          <a:ln/>
-        </p:spPr>
-        <p:txBody>
-          <a:bodyPr wrap="square" rtlCol="0" anchor="ctr"/>
-          <a:lstStyle/>
-          <a:p>
-            <a:pPr indent="0" marL="0">
-              <a:buNone/>
-            </a:pPr>
-            <a:r>
-              <a:rPr lang="en-US" sz="1200" b="1" dirty="0">
-                <a:solidFill>
-                  <a:srgbClr val="FF2D55"/>
-                </a:solidFill>
-                <a:latin typeface="Calibri" pitchFamily="34" charset="0"/>
-                <a:ea typeface="Calibri" pitchFamily="34" charset="-122"/>
-                <a:cs typeface="Calibri" pitchFamily="34" charset="-120"/>
-              </a:rPr>
-              <a:t>TikTok Ads</a:t>
-            </a:r>
-            <a:endParaRPr lang="en-US" sz="1200" dirty="0"/>
-          </a:p>
-        </p:txBody>
-      </p:sp>
-      <p:sp>
-        <p:nvSpPr>
-          <p:cNvPr id="16" name="Shape 14"/>
-          <p:cNvSpPr/>
-          <p:nvPr/>
-        </p:nvSpPr>
-        <p:spPr>
-          <a:xfrm>
-            <a:off x="5943600" y="1463040"/>
-            <a:ext cx="2651760" cy="347472"/>
-          </a:xfrm>
-          <a:prstGeom prst="rect">
-            <a:avLst/>
-          </a:prstGeom>
-          <a:solidFill>
-            <a:srgbClr val="40A0FF">
-              <a:alpha val="12000"/>
-            </a:srgbClr>
-          </a:solidFill>
-          <a:ln w="10160">
-            <a:solidFill>
-              <a:srgbClr val="40A0FF"/>
-            </a:solidFill>
-            <a:prstDash val="solid"/>
-          </a:ln>
-        </p:spPr>
-      </p:sp>
-      <p:sp>
-        <p:nvSpPr>
-          <p:cNvPr id="17" name="Text 15"/>
-          <p:cNvSpPr/>
-          <p:nvPr/>
-        </p:nvSpPr>
-        <p:spPr>
-          <a:xfrm>
-            <a:off x="6080760" y="1463040"/>
-            <a:ext cx="2651760" cy="347472"/>
-          </a:xfrm>
-          <a:prstGeom prst="rect">
-            <a:avLst/>
-          </a:prstGeom>
-          <a:noFill/>
-          <a:ln/>
-        </p:spPr>
-        <p:txBody>
-          <a:bodyPr wrap="square" rtlCol="0" anchor="ctr"/>
-          <a:lstStyle/>
-          <a:p>
-            <a:pPr indent="0" marL="0">
-              <a:buNone/>
-            </a:pPr>
-            <a:r>
-              <a:rPr lang="en-US" sz="1200" b="1" dirty="0">
-                <a:solidFill>
-                  <a:srgbClr val="40A0FF"/>
-                </a:solidFill>
-                <a:latin typeface="Calibri" pitchFamily="34" charset="0"/>
-                <a:ea typeface="Calibri" pitchFamily="34" charset="-122"/>
-                <a:cs typeface="Calibri" pitchFamily="34" charset="-120"/>
-              </a:rPr>
-              <a:t>Meta / Instagram</a:t>
-            </a:r>
-            <a:endParaRPr lang="en-US" sz="1200" dirty="0"/>
-          </a:p>
-        </p:txBody>
-      </p:sp>
-      <p:sp>
-        <p:nvSpPr>
-          <p:cNvPr id="18" name="Shape 16"/>
-          <p:cNvSpPr/>
-          <p:nvPr/>
-        </p:nvSpPr>
-        <p:spPr>
-          <a:xfrm>
-            <a:off x="5943600" y="2011680"/>
-            <a:ext cx="2651760" cy="347472"/>
-          </a:xfrm>
-          <a:prstGeom prst="rect">
-            <a:avLst/>
-          </a:prstGeom>
-          <a:solidFill>
-            <a:srgbClr val="FF6A35">
-              <a:alpha val="12000"/>
-            </a:srgbClr>
-          </a:solidFill>
-          <a:ln w="10160">
-            <a:solidFill>
-              <a:srgbClr val="FF6A35"/>
-            </a:solidFill>
-            <a:prstDash val="solid"/>
-          </a:ln>
-        </p:spPr>
-      </p:sp>
-      <p:sp>
-        <p:nvSpPr>
-          <p:cNvPr id="19" name="Text 17"/>
-          <p:cNvSpPr/>
-          <p:nvPr/>
-        </p:nvSpPr>
-        <p:spPr>
-          <a:xfrm>
-            <a:off x="6080760" y="2011680"/>
-            <a:ext cx="2651760" cy="347472"/>
-          </a:xfrm>
-          <a:prstGeom prst="rect">
-            <a:avLst/>
-          </a:prstGeom>
-          <a:noFill/>
-          <a:ln/>
-        </p:spPr>
-        <p:txBody>
-          <a:bodyPr wrap="square" rtlCol="0" anchor="ctr"/>
-          <a:lstStyle/>
-          <a:p>
-            <a:pPr indent="0" marL="0">
-              <a:buNone/>
-            </a:pPr>
-            <a:r>
-              <a:rPr lang="en-US" sz="1200" b="1" dirty="0">
-                <a:solidFill>
-                  <a:srgbClr val="FF6A35"/>
-                </a:solidFill>
-                <a:latin typeface="Calibri" pitchFamily="34" charset="0"/>
-                <a:ea typeface="Calibri" pitchFamily="34" charset="-122"/>
-                <a:cs typeface="Calibri" pitchFamily="34" charset="-120"/>
-              </a:rPr>
-              <a:t>Reddit Ads</a:t>
-            </a:r>
-            <a:endParaRPr lang="en-US" sz="1200" dirty="0"/>
-          </a:p>
-        </p:txBody>
-      </p:sp>
-      <p:sp>
-        <p:nvSpPr>
-          <p:cNvPr id="20" name="Shape 18"/>
-          <p:cNvSpPr/>
-          <p:nvPr/>
-        </p:nvSpPr>
-        <p:spPr>
-          <a:xfrm>
-            <a:off x="5943600" y="2560320"/>
-            <a:ext cx="2651760" cy="347472"/>
-          </a:xfrm>
-          <a:prstGeom prst="rect">
-            <a:avLst/>
-          </a:prstGeom>
-          <a:solidFill>
-            <a:srgbClr val="FC4C02">
-              <a:alpha val="12000"/>
-            </a:srgbClr>
-          </a:solidFill>
-          <a:ln w="10160">
-            <a:solidFill>
-              <a:srgbClr val="FC4C02"/>
-            </a:solidFill>
-            <a:prstDash val="solid"/>
-          </a:ln>
-        </p:spPr>
-      </p:sp>
-      <p:sp>
-        <p:nvSpPr>
-          <p:cNvPr id="21" name="Text 19"/>
           <p:cNvSpPr/>
           <p:nvPr/>
         </p:nvSpPr>
@@ -2679,7 +2463,7 @@
       </p:sp>
       <p:sp>
         <p:nvSpPr>
-          <p:cNvPr id="22" name="Shape 20"/>
+          <p:cNvPr id="14" name="Shape 12"/>
           <p:cNvSpPr/>
           <p:nvPr/>
         </p:nvSpPr>
@@ -2706,7 +2490,7 @@
       </p:sp>
       <p:sp>
         <p:nvSpPr>
-          <p:cNvPr id="23" name="Text 21"/>
+          <p:cNvPr id="15" name="Text 13"/>
           <p:cNvSpPr/>
           <p:nvPr/>
         </p:nvSpPr>
@@ -2745,7 +2529,7 @@
       </p:sp>
       <p:sp>
         <p:nvSpPr>
-          <p:cNvPr id="24" name="Shape 22"/>
+          <p:cNvPr id="16" name="Shape 14"/>
           <p:cNvSpPr/>
           <p:nvPr/>
         </p:nvSpPr>
@@ -2768,7 +2552,7 @@
       </p:sp>
       <p:sp>
         <p:nvSpPr>
-          <p:cNvPr id="25" name="Text 23"/>
+          <p:cNvPr id="17" name="Text 15"/>
           <p:cNvSpPr/>
           <p:nvPr/>
         </p:nvSpPr>

</xml_diff>